<commit_message>
feat(workplaces): open the Nebius Investigator to guest workplaces
Field reports, investigations and cases run on the sponsor's Nebius tokens, so
guests may use them. Ask Compass and /compass stay closed. Corrects the demo
story and deck: the Nebius key is set on the deployment and was confirmed with a
live Nemotron call on 2026-10-26.

Co-Authored-By: Claude Haiku 5.5 <noreply@anthropic.com>
</commit_message>
<xml_diff>
--- a/docs/nebius/deck/ResponseCompass-nebius-deck.pptx
+++ b/docs/nebius/deck/ResponseCompass-nebius-deck.pptx
@@ -1152,7 +1152,7 @@
           <a:lstStyle/>
           <a:p>
             <a:r>
-              <a:t>Judges sign in with a valid username and the shared guest password. Each username gets its own workplace, copied from the full plant-1 history. New usernames close after ten registered workplaces, to limit bot sign-ups. Field reports and the Investigator are operator-only on guest workplaces until the access decision is made.</a:t>
+              <a:t>Judges sign in with a valid username and the shared guest password. Each username gets its own workplace, copied from the full plant-1 history. New usernames close after ten registered workplaces, to limit bot sign-ups. Field reports and the Investigator are open to guest workplaces, paid from the sponsor's Nebius tokens.</a:t>
             </a:r>
           </a:p>
         </p:txBody>
@@ -12499,13 +12499,12 @@
             </a:avLst>
           </a:prstGeom>
           <a:solidFill>
-            <a:srgbClr val="FFF7ED"/>
+            <a:srgbClr val="FFFFFF"/>
           </a:solidFill>
           <a:ln w="12700">
             <a:solidFill>
-              <a:srgbClr val="D97706"/>
+              <a:srgbClr val="D0D5DD"/>
             </a:solidFill>
-            <a:prstDash val="dash"/>
           </a:ln>
           <a:effectLst/>
         </p:spPr>
@@ -12524,29 +12523,87 @@
           </a:fontRef>
         </p:style>
         <p:txBody>
-          <a:bodyPr rtlCol="0" anchor="ctr" wrap="square" lIns="228600" rIns="228600"/>
+          <a:bodyPr rtlCol="0" anchor="ctr"/>
           <a:lstStyle/>
           <a:p>
             <a:pPr algn="ctr"/>
-            <a:r>
-              <a:rPr sz="1300" b="1">
-                <a:solidFill>
-                  <a:srgbClr val="92400E"/>
-                </a:solidFill>
-                <a:latin typeface="Inter"/>
-              </a:rPr>
-              <a:t>Access decision pending</a:t>
-            </a:r>
-          </a:p>
-          <a:p>
-            <a:r>
-              <a:rPr sz="1200" b="0">
-                <a:solidFill>
-                  <a:srgbClr val="92400E"/>
-                </a:solidFill>
-                <a:latin typeface="Inter"/>
-              </a:rPr>
-              <a:t>Field reports and the Investigator are closed on guest workplaces. Judges cannot reach the Nemotron Investigator until the owner decides whether to open it, and the Nebius key is set on the server.</a:t>
+          </a:p>
+        </p:txBody>
+      </p:sp>
+      <p:sp>
+        <p:nvSpPr>
+          <p:cNvPr id="17" name="TextBox 16"/>
+          <p:cNvSpPr txBox="1"/>
+          <p:nvPr/>
+        </p:nvSpPr>
+        <p:spPr>
+          <a:xfrm>
+            <a:off x="822960" y="4526280"/>
+            <a:ext cx="10515600" cy="365760"/>
+          </a:xfrm>
+          <a:prstGeom prst="rect">
+            <a:avLst/>
+          </a:prstGeom>
+          <a:noFill/>
+        </p:spPr>
+        <p:txBody>
+          <a:bodyPr wrap="square" anchor="t" lIns="18288" rIns="18288" tIns="18288" bIns="18288">
+            <a:spAutoFit/>
+          </a:bodyPr>
+          <a:lstStyle/>
+          <a:p>
+            <a:pPr algn="l">
+              <a:spcAft>
+                <a:spcPts val="0"/>
+              </a:spcAft>
+            </a:pPr>
+            <a:r>
+              <a:rPr sz="1400" b="1">
+                <a:solidFill>
+                  <a:srgbClr val="111827"/>
+                </a:solidFill>
+                <a:latin typeface="Inter"/>
+              </a:rPr>
+              <a:t>The Investigator is open to judges</a:t>
+            </a:r>
+          </a:p>
+        </p:txBody>
+      </p:sp>
+      <p:sp>
+        <p:nvSpPr>
+          <p:cNvPr id="18" name="TextBox 17"/>
+          <p:cNvSpPr txBox="1"/>
+          <p:nvPr/>
+        </p:nvSpPr>
+        <p:spPr>
+          <a:xfrm>
+            <a:off x="822960" y="4892040"/>
+            <a:ext cx="10515600" cy="457200"/>
+          </a:xfrm>
+          <a:prstGeom prst="rect">
+            <a:avLst/>
+          </a:prstGeom>
+          <a:noFill/>
+        </p:spPr>
+        <p:txBody>
+          <a:bodyPr wrap="square" anchor="t" lIns="18288" rIns="18288" tIns="18288" bIns="18288">
+            <a:spAutoFit/>
+          </a:bodyPr>
+          <a:lstStyle/>
+          <a:p>
+            <a:pPr algn="l">
+              <a:spcAft>
+                <a:spcPts val="0"/>
+              </a:spcAft>
+            </a:pPr>
+            <a:r>
+              <a:rPr sz="1300" b="0">
+                <a:solidFill>
+                  <a:srgbClr val="475467"/>
+                </a:solidFill>
+                <a:latin typeface="Inter"/>
+              </a:rPr>
+              <a:t>Field reports and the Investigator run on guest workplaces with the sponsor's Nebius tokens. Ask Compass stays closed.</a:t>
             </a:r>
           </a:p>
         </p:txBody>
@@ -14861,7 +14918,7 @@
                 </a:solidFill>
                 <a:latin typeface="Inter"/>
               </a:rPr>
-              <a:t>Nebius key set on the server, then a live Nemotron check and captures for the Investigator slides.</a:t>
+              <a:t>Captured Investigator run on the deployment, to replace the placeholder on slide 8.</a:t>
             </a:r>
           </a:p>
           <a:p>
@@ -22738,7 +22795,7 @@
                 </a:solidFill>
                 <a:latin typeface="Inter"/>
               </a:rPr>
-              <a:t>The Nebius key is not yet set on the deployment, and field reports are closed to guest workplaces (access decision pending). Replace this box with a live Nemotron capture before filing. Nothing here is a model output.</a:t>
+              <a:t>The Nebius key is set on the deployment, and a live Nemotron call succeeded on 2026-10-26. Replace this box with a captured Investigator run before filing. Nothing here is a model output.</a:t>
             </a:r>
           </a:p>
         </p:txBody>

</xml_diff>